<commit_message>
ders: paftaları A3 yatay düzene çevir
Solda kaynak sütunu, sağda çizim karesi. Kare gövde yüksekliğine
oturuyor (23,8 x 23,8 cm) ve sağ kenarı sayfa kenar boşluğuyla hizalı.

Sol sütun yukarıdan aşağı: kimlik satırı (ad soyad / öğrenci no / tarih),
künye satırı (şiirin adı-şair veya eser adı-sanatçı), kaynak alanı
(şiir; şarkıda karekod + sözler) ve duygular kutusu. Tüm kutular tek
oluk ölçüsüyle aynı ızgaraya oturuyor, sol ve sağ sütunun üst ve alt
kenarları birebir aynı hizada.

Co-Authored-By: Claude Opus 5 <noreply@anthropic.com>
Claude-Session: https://claude.ai/code/session_01Q191QudZw4KFJnN6q2R5gJ
</commit_message>
<xml_diff>
--- a/ders/serbest-cizim-teknikleri/08-cizgilerle-siir-sarki-pafta-A3.pptx
+++ b/ders/serbest-cizim-teknikleri/08-cizgilerle-siir-sarki-pafta-A3.pptx
@@ -11,8 +11,8 @@
   <p:notesMasterIdLst>
     <p:notesMasterId r:id="rId4"/>
   </p:notesMasterIdLst>
-  <p:sldSz cx="10689336" cy="15124176"/>
-  <p:notesSz cx="15124176" cy="10689336"/>
+  <p:sldSz cx="15124176" cy="10689336"/>
+  <p:notesSz cx="10689336" cy="15124176"/>
   <p:defaultTextStyle>
     <a:lvl1pPr marL="0" algn="l" defTabSz="914400" rtl="0" eaLnBrk="1" latinLnBrk="0" hangingPunct="1">
       <a:defRPr sz="1800" kern="1200">
@@ -972,8 +972,8 @@
         </p:nvSpPr>
         <p:spPr>
           <a:xfrm>
-            <a:off x="685800" y="530352"/>
-            <a:ext cx="9317736" cy="164592"/>
+            <a:off x="640080" y="502920"/>
+            <a:ext cx="13844016" cy="164592"/>
           </a:xfrm>
           <a:prstGeom prst="rect">
             <a:avLst/>
@@ -1011,8 +1011,8 @@
         </p:nvSpPr>
         <p:spPr>
           <a:xfrm>
-            <a:off x="685800" y="749808"/>
-            <a:ext cx="9317736" cy="365760"/>
+            <a:off x="640080" y="722376"/>
+            <a:ext cx="13844016" cy="365760"/>
           </a:xfrm>
           <a:prstGeom prst="rect">
             <a:avLst/>
@@ -1050,8 +1050,8 @@
         </p:nvSpPr>
         <p:spPr>
           <a:xfrm>
-            <a:off x="685800" y="1280160"/>
-            <a:ext cx="3108960" cy="3474720"/>
+            <a:off x="640080" y="1298448"/>
+            <a:ext cx="1554480" cy="713232"/>
           </a:xfrm>
           <a:prstGeom prst="rect">
             <a:avLst/>
@@ -1072,8 +1072,313 @@
         </p:nvSpPr>
         <p:spPr>
           <a:xfrm>
-            <a:off x="813816" y="1389888"/>
-            <a:ext cx="2852928" cy="182880"/>
+            <a:off x="768096" y="1408176"/>
+            <a:ext cx="1298448" cy="182880"/>
+          </a:xfrm>
+          <a:prstGeom prst="rect">
+            <a:avLst/>
+          </a:prstGeom>
+          <a:noFill/>
+          <a:ln/>
+        </p:spPr>
+        <p:txBody>
+          <a:bodyPr wrap="square" lIns="0" tIns="0" rIns="0" bIns="0" rtlCol="0" anchor="ctr"/>
+          <a:lstStyle/>
+          <a:p>
+            <a:pPr indent="0" marL="0">
+              <a:buNone/>
+            </a:pPr>
+            <a:r>
+              <a:rPr lang="en-US" sz="950" b="1" spc="80" kern="0" dirty="0">
+                <a:solidFill>
+                  <a:srgbClr val="1A1A1A"/>
+                </a:solidFill>
+                <a:latin typeface="Arial" pitchFamily="34" charset="0"/>
+                <a:ea typeface="Arial" pitchFamily="34" charset="-122"/>
+                <a:cs typeface="Arial" pitchFamily="34" charset="-120"/>
+              </a:rPr>
+              <a:t>AD SOYAD</a:t>
+            </a:r>
+            <a:endParaRPr lang="en-US" sz="950" dirty="0"/>
+          </a:p>
+        </p:txBody>
+      </p:sp>
+      <p:sp>
+        <p:nvSpPr>
+          <p:cNvPr id="6" name="Shape 4"/>
+          <p:cNvSpPr/>
+          <p:nvPr/>
+        </p:nvSpPr>
+        <p:spPr>
+          <a:xfrm>
+            <a:off x="2395728" y="1298448"/>
+            <a:ext cx="1554480" cy="713232"/>
+          </a:xfrm>
+          <a:prstGeom prst="rect">
+            <a:avLst/>
+          </a:prstGeom>
+          <a:ln w="12700">
+            <a:solidFill>
+              <a:srgbClr val="1A1A1A"/>
+            </a:solidFill>
+            <a:prstDash val="solid"/>
+          </a:ln>
+        </p:spPr>
+      </p:sp>
+      <p:sp>
+        <p:nvSpPr>
+          <p:cNvPr id="7" name="Text 5"/>
+          <p:cNvSpPr txBox="1"/>
+          <p:nvPr/>
+        </p:nvSpPr>
+        <p:spPr>
+          <a:xfrm>
+            <a:off x="2523744" y="1408176"/>
+            <a:ext cx="1298448" cy="182880"/>
+          </a:xfrm>
+          <a:prstGeom prst="rect">
+            <a:avLst/>
+          </a:prstGeom>
+          <a:noFill/>
+          <a:ln/>
+        </p:spPr>
+        <p:txBody>
+          <a:bodyPr wrap="square" lIns="0" tIns="0" rIns="0" bIns="0" rtlCol="0" anchor="ctr"/>
+          <a:lstStyle/>
+          <a:p>
+            <a:pPr indent="0" marL="0">
+              <a:buNone/>
+            </a:pPr>
+            <a:r>
+              <a:rPr lang="en-US" sz="950" b="1" spc="80" kern="0" dirty="0">
+                <a:solidFill>
+                  <a:srgbClr val="1A1A1A"/>
+                </a:solidFill>
+                <a:latin typeface="Arial" pitchFamily="34" charset="0"/>
+                <a:ea typeface="Arial" pitchFamily="34" charset="-122"/>
+                <a:cs typeface="Arial" pitchFamily="34" charset="-120"/>
+              </a:rPr>
+              <a:t>ÖĞRENCİ NO</a:t>
+            </a:r>
+            <a:endParaRPr lang="en-US" sz="950" dirty="0"/>
+          </a:p>
+        </p:txBody>
+      </p:sp>
+      <p:sp>
+        <p:nvSpPr>
+          <p:cNvPr id="8" name="Shape 6"/>
+          <p:cNvSpPr/>
+          <p:nvPr/>
+        </p:nvSpPr>
+        <p:spPr>
+          <a:xfrm>
+            <a:off x="4151376" y="1298448"/>
+            <a:ext cx="1554480" cy="713232"/>
+          </a:xfrm>
+          <a:prstGeom prst="rect">
+            <a:avLst/>
+          </a:prstGeom>
+          <a:ln w="12700">
+            <a:solidFill>
+              <a:srgbClr val="1A1A1A"/>
+            </a:solidFill>
+            <a:prstDash val="solid"/>
+          </a:ln>
+        </p:spPr>
+      </p:sp>
+      <p:sp>
+        <p:nvSpPr>
+          <p:cNvPr id="9" name="Text 7"/>
+          <p:cNvSpPr txBox="1"/>
+          <p:nvPr/>
+        </p:nvSpPr>
+        <p:spPr>
+          <a:xfrm>
+            <a:off x="4279392" y="1408176"/>
+            <a:ext cx="1298448" cy="182880"/>
+          </a:xfrm>
+          <a:prstGeom prst="rect">
+            <a:avLst/>
+          </a:prstGeom>
+          <a:noFill/>
+          <a:ln/>
+        </p:spPr>
+        <p:txBody>
+          <a:bodyPr wrap="square" lIns="0" tIns="0" rIns="0" bIns="0" rtlCol="0" anchor="ctr"/>
+          <a:lstStyle/>
+          <a:p>
+            <a:pPr indent="0" marL="0">
+              <a:buNone/>
+            </a:pPr>
+            <a:r>
+              <a:rPr lang="en-US" sz="950" b="1" spc="80" kern="0" dirty="0">
+                <a:solidFill>
+                  <a:srgbClr val="1A1A1A"/>
+                </a:solidFill>
+                <a:latin typeface="Arial" pitchFamily="34" charset="0"/>
+                <a:ea typeface="Arial" pitchFamily="34" charset="-122"/>
+                <a:cs typeface="Arial" pitchFamily="34" charset="-120"/>
+              </a:rPr>
+              <a:t>TARİH</a:t>
+            </a:r>
+            <a:endParaRPr lang="en-US" sz="950" dirty="0"/>
+          </a:p>
+        </p:txBody>
+      </p:sp>
+      <p:sp>
+        <p:nvSpPr>
+          <p:cNvPr id="10" name="Shape 8"/>
+          <p:cNvSpPr/>
+          <p:nvPr/>
+        </p:nvSpPr>
+        <p:spPr>
+          <a:xfrm>
+            <a:off x="640080" y="2212848"/>
+            <a:ext cx="2432304" cy="841248"/>
+          </a:xfrm>
+          <a:prstGeom prst="rect">
+            <a:avLst/>
+          </a:prstGeom>
+          <a:ln w="12700">
+            <a:solidFill>
+              <a:srgbClr val="1A1A1A"/>
+            </a:solidFill>
+            <a:prstDash val="solid"/>
+          </a:ln>
+        </p:spPr>
+      </p:sp>
+      <p:sp>
+        <p:nvSpPr>
+          <p:cNvPr id="11" name="Text 9"/>
+          <p:cNvSpPr txBox="1"/>
+          <p:nvPr/>
+        </p:nvSpPr>
+        <p:spPr>
+          <a:xfrm>
+            <a:off x="768096" y="2322576"/>
+            <a:ext cx="2176272" cy="182880"/>
+          </a:xfrm>
+          <a:prstGeom prst="rect">
+            <a:avLst/>
+          </a:prstGeom>
+          <a:noFill/>
+          <a:ln/>
+        </p:spPr>
+        <p:txBody>
+          <a:bodyPr wrap="square" lIns="0" tIns="0" rIns="0" bIns="0" rtlCol="0" anchor="ctr"/>
+          <a:lstStyle/>
+          <a:p>
+            <a:pPr indent="0" marL="0">
+              <a:buNone/>
+            </a:pPr>
+            <a:r>
+              <a:rPr lang="en-US" sz="950" b="1" spc="80" kern="0" dirty="0">
+                <a:solidFill>
+                  <a:srgbClr val="1A1A1A"/>
+                </a:solidFill>
+                <a:latin typeface="Arial" pitchFamily="34" charset="0"/>
+                <a:ea typeface="Arial" pitchFamily="34" charset="-122"/>
+                <a:cs typeface="Arial" pitchFamily="34" charset="-120"/>
+              </a:rPr>
+              <a:t>ŞİİRİN ADI</a:t>
+            </a:r>
+            <a:endParaRPr lang="en-US" sz="950" dirty="0"/>
+          </a:p>
+        </p:txBody>
+      </p:sp>
+      <p:sp>
+        <p:nvSpPr>
+          <p:cNvPr id="12" name="Shape 10"/>
+          <p:cNvSpPr/>
+          <p:nvPr/>
+        </p:nvSpPr>
+        <p:spPr>
+          <a:xfrm>
+            <a:off x="3273552" y="2212848"/>
+            <a:ext cx="2432304" cy="841248"/>
+          </a:xfrm>
+          <a:prstGeom prst="rect">
+            <a:avLst/>
+          </a:prstGeom>
+          <a:ln w="12700">
+            <a:solidFill>
+              <a:srgbClr val="1A1A1A"/>
+            </a:solidFill>
+            <a:prstDash val="solid"/>
+          </a:ln>
+        </p:spPr>
+      </p:sp>
+      <p:sp>
+        <p:nvSpPr>
+          <p:cNvPr id="13" name="Text 11"/>
+          <p:cNvSpPr txBox="1"/>
+          <p:nvPr/>
+        </p:nvSpPr>
+        <p:spPr>
+          <a:xfrm>
+            <a:off x="3401568" y="2322576"/>
+            <a:ext cx="2176272" cy="182880"/>
+          </a:xfrm>
+          <a:prstGeom prst="rect">
+            <a:avLst/>
+          </a:prstGeom>
+          <a:noFill/>
+          <a:ln/>
+        </p:spPr>
+        <p:txBody>
+          <a:bodyPr wrap="square" lIns="0" tIns="0" rIns="0" bIns="0" rtlCol="0" anchor="ctr"/>
+          <a:lstStyle/>
+          <a:p>
+            <a:pPr indent="0" marL="0">
+              <a:buNone/>
+            </a:pPr>
+            <a:r>
+              <a:rPr lang="en-US" sz="950" b="1" spc="80" kern="0" dirty="0">
+                <a:solidFill>
+                  <a:srgbClr val="1A1A1A"/>
+                </a:solidFill>
+                <a:latin typeface="Arial" pitchFamily="34" charset="0"/>
+                <a:ea typeface="Arial" pitchFamily="34" charset="-122"/>
+                <a:cs typeface="Arial" pitchFamily="34" charset="-120"/>
+              </a:rPr>
+              <a:t>ŞAİR</a:t>
+            </a:r>
+            <a:endParaRPr lang="en-US" sz="950" dirty="0"/>
+          </a:p>
+        </p:txBody>
+      </p:sp>
+      <p:sp>
+        <p:nvSpPr>
+          <p:cNvPr id="14" name="Shape 12"/>
+          <p:cNvSpPr/>
+          <p:nvPr/>
+        </p:nvSpPr>
+        <p:spPr>
+          <a:xfrm>
+            <a:off x="640080" y="3255264"/>
+            <a:ext cx="5065776" cy="4526280"/>
+          </a:xfrm>
+          <a:prstGeom prst="rect">
+            <a:avLst/>
+          </a:prstGeom>
+          <a:ln w="12700">
+            <a:solidFill>
+              <a:srgbClr val="1A1A1A"/>
+            </a:solidFill>
+            <a:prstDash val="solid"/>
+          </a:ln>
+        </p:spPr>
+      </p:sp>
+      <p:sp>
+        <p:nvSpPr>
+          <p:cNvPr id="15" name="Text 13"/>
+          <p:cNvSpPr txBox="1"/>
+          <p:nvPr/>
+        </p:nvSpPr>
+        <p:spPr>
+          <a:xfrm>
+            <a:off x="768096" y="3364992"/>
+            <a:ext cx="4809744" cy="182880"/>
           </a:xfrm>
           <a:prstGeom prst="rect">
             <a:avLst/>
@@ -1105,14 +1410,14 @@
       </p:sp>
       <p:sp>
         <p:nvSpPr>
-          <p:cNvPr id="6" name="Shape 4"/>
+          <p:cNvPr id="16" name="Shape 14"/>
           <p:cNvSpPr/>
           <p:nvPr/>
         </p:nvSpPr>
         <p:spPr>
           <a:xfrm>
-            <a:off x="3995928" y="1280160"/>
-            <a:ext cx="1868424" cy="713232"/>
+            <a:off x="640080" y="7982712"/>
+            <a:ext cx="5065776" cy="1892808"/>
           </a:xfrm>
           <a:prstGeom prst="rect">
             <a:avLst/>
@@ -1127,319 +1432,14 @@
       </p:sp>
       <p:sp>
         <p:nvSpPr>
-          <p:cNvPr id="7" name="Text 5"/>
-          <p:cNvSpPr txBox="1"/>
-          <p:nvPr/>
-        </p:nvSpPr>
-        <p:spPr>
-          <a:xfrm>
-            <a:off x="4123944" y="1389888"/>
-            <a:ext cx="1612392" cy="182880"/>
-          </a:xfrm>
-          <a:prstGeom prst="rect">
-            <a:avLst/>
-          </a:prstGeom>
-          <a:noFill/>
-          <a:ln/>
-        </p:spPr>
-        <p:txBody>
-          <a:bodyPr wrap="square" lIns="0" tIns="0" rIns="0" bIns="0" rtlCol="0" anchor="ctr"/>
-          <a:lstStyle/>
-          <a:p>
-            <a:pPr indent="0" marL="0">
-              <a:buNone/>
-            </a:pPr>
-            <a:r>
-              <a:rPr lang="en-US" sz="950" b="1" spc="80" kern="0" dirty="0">
-                <a:solidFill>
-                  <a:srgbClr val="1A1A1A"/>
-                </a:solidFill>
-                <a:latin typeface="Arial" pitchFamily="34" charset="0"/>
-                <a:ea typeface="Arial" pitchFamily="34" charset="-122"/>
-                <a:cs typeface="Arial" pitchFamily="34" charset="-120"/>
-              </a:rPr>
-              <a:t>AD SOYAD</a:t>
-            </a:r>
-            <a:endParaRPr lang="en-US" sz="950" dirty="0"/>
-          </a:p>
-        </p:txBody>
-      </p:sp>
-      <p:sp>
-        <p:nvSpPr>
-          <p:cNvPr id="8" name="Shape 6"/>
-          <p:cNvSpPr/>
-          <p:nvPr/>
-        </p:nvSpPr>
-        <p:spPr>
-          <a:xfrm>
-            <a:off x="6065520" y="1280160"/>
-            <a:ext cx="1868424" cy="713232"/>
-          </a:xfrm>
-          <a:prstGeom prst="rect">
-            <a:avLst/>
-          </a:prstGeom>
-          <a:ln w="12700">
-            <a:solidFill>
-              <a:srgbClr val="1A1A1A"/>
-            </a:solidFill>
-            <a:prstDash val="solid"/>
-          </a:ln>
-        </p:spPr>
-      </p:sp>
-      <p:sp>
-        <p:nvSpPr>
-          <p:cNvPr id="9" name="Text 7"/>
-          <p:cNvSpPr txBox="1"/>
-          <p:nvPr/>
-        </p:nvSpPr>
-        <p:spPr>
-          <a:xfrm>
-            <a:off x="6193536" y="1389888"/>
-            <a:ext cx="1612392" cy="182880"/>
-          </a:xfrm>
-          <a:prstGeom prst="rect">
-            <a:avLst/>
-          </a:prstGeom>
-          <a:noFill/>
-          <a:ln/>
-        </p:spPr>
-        <p:txBody>
-          <a:bodyPr wrap="square" lIns="0" tIns="0" rIns="0" bIns="0" rtlCol="0" anchor="ctr"/>
-          <a:lstStyle/>
-          <a:p>
-            <a:pPr indent="0" marL="0">
-              <a:buNone/>
-            </a:pPr>
-            <a:r>
-              <a:rPr lang="en-US" sz="950" b="1" spc="80" kern="0" dirty="0">
-                <a:solidFill>
-                  <a:srgbClr val="1A1A1A"/>
-                </a:solidFill>
-                <a:latin typeface="Arial" pitchFamily="34" charset="0"/>
-                <a:ea typeface="Arial" pitchFamily="34" charset="-122"/>
-                <a:cs typeface="Arial" pitchFamily="34" charset="-120"/>
-              </a:rPr>
-              <a:t>ÖĞRENCİ NO</a:t>
-            </a:r>
-            <a:endParaRPr lang="en-US" sz="950" dirty="0"/>
-          </a:p>
-        </p:txBody>
-      </p:sp>
-      <p:sp>
-        <p:nvSpPr>
-          <p:cNvPr id="10" name="Shape 8"/>
-          <p:cNvSpPr/>
-          <p:nvPr/>
-        </p:nvSpPr>
-        <p:spPr>
-          <a:xfrm>
-            <a:off x="8135112" y="1280160"/>
-            <a:ext cx="1868424" cy="713232"/>
-          </a:xfrm>
-          <a:prstGeom prst="rect">
-            <a:avLst/>
-          </a:prstGeom>
-          <a:ln w="12700">
-            <a:solidFill>
-              <a:srgbClr val="1A1A1A"/>
-            </a:solidFill>
-            <a:prstDash val="solid"/>
-          </a:ln>
-        </p:spPr>
-      </p:sp>
-      <p:sp>
-        <p:nvSpPr>
-          <p:cNvPr id="11" name="Text 9"/>
-          <p:cNvSpPr txBox="1"/>
-          <p:nvPr/>
-        </p:nvSpPr>
-        <p:spPr>
-          <a:xfrm>
-            <a:off x="8263128" y="1389888"/>
-            <a:ext cx="1612392" cy="182880"/>
-          </a:xfrm>
-          <a:prstGeom prst="rect">
-            <a:avLst/>
-          </a:prstGeom>
-          <a:noFill/>
-          <a:ln/>
-        </p:spPr>
-        <p:txBody>
-          <a:bodyPr wrap="square" lIns="0" tIns="0" rIns="0" bIns="0" rtlCol="0" anchor="ctr"/>
-          <a:lstStyle/>
-          <a:p>
-            <a:pPr indent="0" marL="0">
-              <a:buNone/>
-            </a:pPr>
-            <a:r>
-              <a:rPr lang="en-US" sz="950" b="1" spc="80" kern="0" dirty="0">
-                <a:solidFill>
-                  <a:srgbClr val="1A1A1A"/>
-                </a:solidFill>
-                <a:latin typeface="Arial" pitchFamily="34" charset="0"/>
-                <a:ea typeface="Arial" pitchFamily="34" charset="-122"/>
-                <a:cs typeface="Arial" pitchFamily="34" charset="-120"/>
-              </a:rPr>
-              <a:t>TARİH</a:t>
-            </a:r>
-            <a:endParaRPr lang="en-US" sz="950" dirty="0"/>
-          </a:p>
-        </p:txBody>
-      </p:sp>
-      <p:sp>
-        <p:nvSpPr>
-          <p:cNvPr id="12" name="Shape 10"/>
-          <p:cNvSpPr/>
-          <p:nvPr/>
-        </p:nvSpPr>
-        <p:spPr>
-          <a:xfrm>
-            <a:off x="3995928" y="2194560"/>
-            <a:ext cx="2903220" cy="841248"/>
-          </a:xfrm>
-          <a:prstGeom prst="rect">
-            <a:avLst/>
-          </a:prstGeom>
-          <a:ln w="12700">
-            <a:solidFill>
-              <a:srgbClr val="1A1A1A"/>
-            </a:solidFill>
-            <a:prstDash val="solid"/>
-          </a:ln>
-        </p:spPr>
-      </p:sp>
-      <p:sp>
-        <p:nvSpPr>
-          <p:cNvPr id="13" name="Text 11"/>
-          <p:cNvSpPr txBox="1"/>
-          <p:nvPr/>
-        </p:nvSpPr>
-        <p:spPr>
-          <a:xfrm>
-            <a:off x="4123944" y="2304288"/>
-            <a:ext cx="2647188" cy="182880"/>
-          </a:xfrm>
-          <a:prstGeom prst="rect">
-            <a:avLst/>
-          </a:prstGeom>
-          <a:noFill/>
-          <a:ln/>
-        </p:spPr>
-        <p:txBody>
-          <a:bodyPr wrap="square" lIns="0" tIns="0" rIns="0" bIns="0" rtlCol="0" anchor="ctr"/>
-          <a:lstStyle/>
-          <a:p>
-            <a:pPr indent="0" marL="0">
-              <a:buNone/>
-            </a:pPr>
-            <a:r>
-              <a:rPr lang="en-US" sz="950" b="1" spc="80" kern="0" dirty="0">
-                <a:solidFill>
-                  <a:srgbClr val="1A1A1A"/>
-                </a:solidFill>
-                <a:latin typeface="Arial" pitchFamily="34" charset="0"/>
-                <a:ea typeface="Arial" pitchFamily="34" charset="-122"/>
-                <a:cs typeface="Arial" pitchFamily="34" charset="-120"/>
-              </a:rPr>
-              <a:t>ŞİİRİN ADI</a:t>
-            </a:r>
-            <a:endParaRPr lang="en-US" sz="950" dirty="0"/>
-          </a:p>
-        </p:txBody>
-      </p:sp>
-      <p:sp>
-        <p:nvSpPr>
-          <p:cNvPr id="14" name="Shape 12"/>
-          <p:cNvSpPr/>
-          <p:nvPr/>
-        </p:nvSpPr>
-        <p:spPr>
-          <a:xfrm>
-            <a:off x="7100316" y="2194560"/>
-            <a:ext cx="2903220" cy="841248"/>
-          </a:xfrm>
-          <a:prstGeom prst="rect">
-            <a:avLst/>
-          </a:prstGeom>
-          <a:ln w="12700">
-            <a:solidFill>
-              <a:srgbClr val="1A1A1A"/>
-            </a:solidFill>
-            <a:prstDash val="solid"/>
-          </a:ln>
-        </p:spPr>
-      </p:sp>
-      <p:sp>
-        <p:nvSpPr>
-          <p:cNvPr id="15" name="Text 13"/>
-          <p:cNvSpPr txBox="1"/>
-          <p:nvPr/>
-        </p:nvSpPr>
-        <p:spPr>
-          <a:xfrm>
-            <a:off x="7228332" y="2304288"/>
-            <a:ext cx="2647188" cy="182880"/>
-          </a:xfrm>
-          <a:prstGeom prst="rect">
-            <a:avLst/>
-          </a:prstGeom>
-          <a:noFill/>
-          <a:ln/>
-        </p:spPr>
-        <p:txBody>
-          <a:bodyPr wrap="square" lIns="0" tIns="0" rIns="0" bIns="0" rtlCol="0" anchor="ctr"/>
-          <a:lstStyle/>
-          <a:p>
-            <a:pPr indent="0" marL="0">
-              <a:buNone/>
-            </a:pPr>
-            <a:r>
-              <a:rPr lang="en-US" sz="950" b="1" spc="80" kern="0" dirty="0">
-                <a:solidFill>
-                  <a:srgbClr val="1A1A1A"/>
-                </a:solidFill>
-                <a:latin typeface="Arial" pitchFamily="34" charset="0"/>
-                <a:ea typeface="Arial" pitchFamily="34" charset="-122"/>
-                <a:cs typeface="Arial" pitchFamily="34" charset="-120"/>
-              </a:rPr>
-              <a:t>ŞAİR</a:t>
-            </a:r>
-            <a:endParaRPr lang="en-US" sz="950" dirty="0"/>
-          </a:p>
-        </p:txBody>
-      </p:sp>
-      <p:sp>
-        <p:nvSpPr>
-          <p:cNvPr id="16" name="Shape 14"/>
-          <p:cNvSpPr/>
-          <p:nvPr/>
-        </p:nvSpPr>
-        <p:spPr>
-          <a:xfrm>
-            <a:off x="3995928" y="3236976"/>
-            <a:ext cx="6007608" cy="1517904"/>
-          </a:xfrm>
-          <a:prstGeom prst="rect">
-            <a:avLst/>
-          </a:prstGeom>
-          <a:ln w="12700">
-            <a:solidFill>
-              <a:srgbClr val="1A1A1A"/>
-            </a:solidFill>
-            <a:prstDash val="solid"/>
-          </a:ln>
-        </p:spPr>
-      </p:sp>
-      <p:sp>
-        <p:nvSpPr>
           <p:cNvPr id="17" name="Text 15"/>
           <p:cNvSpPr txBox="1"/>
           <p:nvPr/>
         </p:nvSpPr>
         <p:spPr>
           <a:xfrm>
-            <a:off x="4123944" y="3346704"/>
-            <a:ext cx="5751576" cy="182880"/>
+            <a:off x="768096" y="8092440"/>
+            <a:ext cx="4809744" cy="182880"/>
           </a:xfrm>
           <a:prstGeom prst="rect">
             <a:avLst/>
@@ -1471,14 +1471,36 @@
       </p:sp>
       <p:sp>
         <p:nvSpPr>
-          <p:cNvPr id="18" name="Text 16"/>
+          <p:cNvPr id="18" name="Shape 16"/>
+          <p:cNvSpPr/>
+          <p:nvPr/>
+        </p:nvSpPr>
+        <p:spPr>
+          <a:xfrm>
+            <a:off x="5907024" y="1298448"/>
+            <a:ext cx="8577072" cy="8577072"/>
+          </a:xfrm>
+          <a:prstGeom prst="rect">
+            <a:avLst/>
+          </a:prstGeom>
+          <a:ln w="12700">
+            <a:solidFill>
+              <a:srgbClr val="1A1A1A"/>
+            </a:solidFill>
+            <a:prstDash val="solid"/>
+          </a:ln>
+        </p:spPr>
+      </p:sp>
+      <p:sp>
+        <p:nvSpPr>
+          <p:cNvPr id="19" name="Text 17"/>
           <p:cNvSpPr txBox="1"/>
           <p:nvPr/>
         </p:nvSpPr>
         <p:spPr>
           <a:xfrm>
-            <a:off x="685800" y="4956048"/>
-            <a:ext cx="9317736" cy="164592"/>
+            <a:off x="6035040" y="1408176"/>
+            <a:ext cx="8321040" cy="182880"/>
           </a:xfrm>
           <a:prstGeom prst="rect">
             <a:avLst/>
@@ -1510,36 +1532,14 @@
       </p:sp>
       <p:sp>
         <p:nvSpPr>
-          <p:cNvPr id="19" name="Shape 17"/>
-          <p:cNvSpPr/>
-          <p:nvPr/>
-        </p:nvSpPr>
-        <p:spPr>
-          <a:xfrm>
-            <a:off x="685800" y="5148072"/>
-            <a:ext cx="9317736" cy="9317736"/>
-          </a:xfrm>
-          <a:prstGeom prst="rect">
-            <a:avLst/>
-          </a:prstGeom>
-          <a:ln w="12700">
-            <a:solidFill>
-              <a:srgbClr val="1A1A1A"/>
-            </a:solidFill>
-            <a:prstDash val="solid"/>
-          </a:ln>
-        </p:spPr>
-      </p:sp>
-      <p:sp>
-        <p:nvSpPr>
           <p:cNvPr id="20" name="Text 18"/>
           <p:cNvSpPr txBox="1"/>
           <p:nvPr/>
         </p:nvSpPr>
         <p:spPr>
           <a:xfrm>
-            <a:off x="685800" y="14593824"/>
-            <a:ext cx="9317736" cy="164592"/>
+            <a:off x="640080" y="10021824"/>
+            <a:ext cx="13844016" cy="164592"/>
           </a:xfrm>
           <a:prstGeom prst="rect">
             <a:avLst/>
@@ -1609,8 +1609,8 @@
         </p:nvSpPr>
         <p:spPr>
           <a:xfrm>
-            <a:off x="685800" y="530352"/>
-            <a:ext cx="9317736" cy="164592"/>
+            <a:off x="640080" y="502920"/>
+            <a:ext cx="13844016" cy="164592"/>
           </a:xfrm>
           <a:prstGeom prst="rect">
             <a:avLst/>
@@ -1648,8 +1648,8 @@
         </p:nvSpPr>
         <p:spPr>
           <a:xfrm>
-            <a:off x="685800" y="749808"/>
-            <a:ext cx="9317736" cy="365760"/>
+            <a:off x="640080" y="722376"/>
+            <a:ext cx="13844016" cy="365760"/>
           </a:xfrm>
           <a:prstGeom prst="rect">
             <a:avLst/>
@@ -1687,8 +1687,8 @@
         </p:nvSpPr>
         <p:spPr>
           <a:xfrm>
-            <a:off x="685800" y="1280160"/>
-            <a:ext cx="3108960" cy="1755648"/>
+            <a:off x="640080" y="1298448"/>
+            <a:ext cx="1554480" cy="713232"/>
           </a:xfrm>
           <a:prstGeom prst="rect">
             <a:avLst/>
@@ -1709,8 +1709,313 @@
         </p:nvSpPr>
         <p:spPr>
           <a:xfrm>
-            <a:off x="813816" y="1389888"/>
-            <a:ext cx="2852928" cy="182880"/>
+            <a:off x="768096" y="1408176"/>
+            <a:ext cx="1298448" cy="182880"/>
+          </a:xfrm>
+          <a:prstGeom prst="rect">
+            <a:avLst/>
+          </a:prstGeom>
+          <a:noFill/>
+          <a:ln/>
+        </p:spPr>
+        <p:txBody>
+          <a:bodyPr wrap="square" lIns="0" tIns="0" rIns="0" bIns="0" rtlCol="0" anchor="ctr"/>
+          <a:lstStyle/>
+          <a:p>
+            <a:pPr indent="0" marL="0">
+              <a:buNone/>
+            </a:pPr>
+            <a:r>
+              <a:rPr lang="en-US" sz="950" b="1" spc="80" kern="0" dirty="0">
+                <a:solidFill>
+                  <a:srgbClr val="1A1A1A"/>
+                </a:solidFill>
+                <a:latin typeface="Arial" pitchFamily="34" charset="0"/>
+                <a:ea typeface="Arial" pitchFamily="34" charset="-122"/>
+                <a:cs typeface="Arial" pitchFamily="34" charset="-120"/>
+              </a:rPr>
+              <a:t>AD SOYAD</a:t>
+            </a:r>
+            <a:endParaRPr lang="en-US" sz="950" dirty="0"/>
+          </a:p>
+        </p:txBody>
+      </p:sp>
+      <p:sp>
+        <p:nvSpPr>
+          <p:cNvPr id="6" name="Shape 4"/>
+          <p:cNvSpPr/>
+          <p:nvPr/>
+        </p:nvSpPr>
+        <p:spPr>
+          <a:xfrm>
+            <a:off x="2395728" y="1298448"/>
+            <a:ext cx="1554480" cy="713232"/>
+          </a:xfrm>
+          <a:prstGeom prst="rect">
+            <a:avLst/>
+          </a:prstGeom>
+          <a:ln w="12700">
+            <a:solidFill>
+              <a:srgbClr val="1A1A1A"/>
+            </a:solidFill>
+            <a:prstDash val="solid"/>
+          </a:ln>
+        </p:spPr>
+      </p:sp>
+      <p:sp>
+        <p:nvSpPr>
+          <p:cNvPr id="7" name="Text 5"/>
+          <p:cNvSpPr txBox="1"/>
+          <p:nvPr/>
+        </p:nvSpPr>
+        <p:spPr>
+          <a:xfrm>
+            <a:off x="2523744" y="1408176"/>
+            <a:ext cx="1298448" cy="182880"/>
+          </a:xfrm>
+          <a:prstGeom prst="rect">
+            <a:avLst/>
+          </a:prstGeom>
+          <a:noFill/>
+          <a:ln/>
+        </p:spPr>
+        <p:txBody>
+          <a:bodyPr wrap="square" lIns="0" tIns="0" rIns="0" bIns="0" rtlCol="0" anchor="ctr"/>
+          <a:lstStyle/>
+          <a:p>
+            <a:pPr indent="0" marL="0">
+              <a:buNone/>
+            </a:pPr>
+            <a:r>
+              <a:rPr lang="en-US" sz="950" b="1" spc="80" kern="0" dirty="0">
+                <a:solidFill>
+                  <a:srgbClr val="1A1A1A"/>
+                </a:solidFill>
+                <a:latin typeface="Arial" pitchFamily="34" charset="0"/>
+                <a:ea typeface="Arial" pitchFamily="34" charset="-122"/>
+                <a:cs typeface="Arial" pitchFamily="34" charset="-120"/>
+              </a:rPr>
+              <a:t>ÖĞRENCİ NO</a:t>
+            </a:r>
+            <a:endParaRPr lang="en-US" sz="950" dirty="0"/>
+          </a:p>
+        </p:txBody>
+      </p:sp>
+      <p:sp>
+        <p:nvSpPr>
+          <p:cNvPr id="8" name="Shape 6"/>
+          <p:cNvSpPr/>
+          <p:nvPr/>
+        </p:nvSpPr>
+        <p:spPr>
+          <a:xfrm>
+            <a:off x="4151376" y="1298448"/>
+            <a:ext cx="1554480" cy="713232"/>
+          </a:xfrm>
+          <a:prstGeom prst="rect">
+            <a:avLst/>
+          </a:prstGeom>
+          <a:ln w="12700">
+            <a:solidFill>
+              <a:srgbClr val="1A1A1A"/>
+            </a:solidFill>
+            <a:prstDash val="solid"/>
+          </a:ln>
+        </p:spPr>
+      </p:sp>
+      <p:sp>
+        <p:nvSpPr>
+          <p:cNvPr id="9" name="Text 7"/>
+          <p:cNvSpPr txBox="1"/>
+          <p:nvPr/>
+        </p:nvSpPr>
+        <p:spPr>
+          <a:xfrm>
+            <a:off x="4279392" y="1408176"/>
+            <a:ext cx="1298448" cy="182880"/>
+          </a:xfrm>
+          <a:prstGeom prst="rect">
+            <a:avLst/>
+          </a:prstGeom>
+          <a:noFill/>
+          <a:ln/>
+        </p:spPr>
+        <p:txBody>
+          <a:bodyPr wrap="square" lIns="0" tIns="0" rIns="0" bIns="0" rtlCol="0" anchor="ctr"/>
+          <a:lstStyle/>
+          <a:p>
+            <a:pPr indent="0" marL="0">
+              <a:buNone/>
+            </a:pPr>
+            <a:r>
+              <a:rPr lang="en-US" sz="950" b="1" spc="80" kern="0" dirty="0">
+                <a:solidFill>
+                  <a:srgbClr val="1A1A1A"/>
+                </a:solidFill>
+                <a:latin typeface="Arial" pitchFamily="34" charset="0"/>
+                <a:ea typeface="Arial" pitchFamily="34" charset="-122"/>
+                <a:cs typeface="Arial" pitchFamily="34" charset="-120"/>
+              </a:rPr>
+              <a:t>TARİH</a:t>
+            </a:r>
+            <a:endParaRPr lang="en-US" sz="950" dirty="0"/>
+          </a:p>
+        </p:txBody>
+      </p:sp>
+      <p:sp>
+        <p:nvSpPr>
+          <p:cNvPr id="10" name="Shape 8"/>
+          <p:cNvSpPr/>
+          <p:nvPr/>
+        </p:nvSpPr>
+        <p:spPr>
+          <a:xfrm>
+            <a:off x="640080" y="2212848"/>
+            <a:ext cx="2432304" cy="841248"/>
+          </a:xfrm>
+          <a:prstGeom prst="rect">
+            <a:avLst/>
+          </a:prstGeom>
+          <a:ln w="12700">
+            <a:solidFill>
+              <a:srgbClr val="1A1A1A"/>
+            </a:solidFill>
+            <a:prstDash val="solid"/>
+          </a:ln>
+        </p:spPr>
+      </p:sp>
+      <p:sp>
+        <p:nvSpPr>
+          <p:cNvPr id="11" name="Text 9"/>
+          <p:cNvSpPr txBox="1"/>
+          <p:nvPr/>
+        </p:nvSpPr>
+        <p:spPr>
+          <a:xfrm>
+            <a:off x="768096" y="2322576"/>
+            <a:ext cx="2176272" cy="182880"/>
+          </a:xfrm>
+          <a:prstGeom prst="rect">
+            <a:avLst/>
+          </a:prstGeom>
+          <a:noFill/>
+          <a:ln/>
+        </p:spPr>
+        <p:txBody>
+          <a:bodyPr wrap="square" lIns="0" tIns="0" rIns="0" bIns="0" rtlCol="0" anchor="ctr"/>
+          <a:lstStyle/>
+          <a:p>
+            <a:pPr indent="0" marL="0">
+              <a:buNone/>
+            </a:pPr>
+            <a:r>
+              <a:rPr lang="en-US" sz="950" b="1" spc="80" kern="0" dirty="0">
+                <a:solidFill>
+                  <a:srgbClr val="1A1A1A"/>
+                </a:solidFill>
+                <a:latin typeface="Arial" pitchFamily="34" charset="0"/>
+                <a:ea typeface="Arial" pitchFamily="34" charset="-122"/>
+                <a:cs typeface="Arial" pitchFamily="34" charset="-120"/>
+              </a:rPr>
+              <a:t>ESER ADI</a:t>
+            </a:r>
+            <a:endParaRPr lang="en-US" sz="950" dirty="0"/>
+          </a:p>
+        </p:txBody>
+      </p:sp>
+      <p:sp>
+        <p:nvSpPr>
+          <p:cNvPr id="12" name="Shape 10"/>
+          <p:cNvSpPr/>
+          <p:nvPr/>
+        </p:nvSpPr>
+        <p:spPr>
+          <a:xfrm>
+            <a:off x="3273552" y="2212848"/>
+            <a:ext cx="2432304" cy="841248"/>
+          </a:xfrm>
+          <a:prstGeom prst="rect">
+            <a:avLst/>
+          </a:prstGeom>
+          <a:ln w="12700">
+            <a:solidFill>
+              <a:srgbClr val="1A1A1A"/>
+            </a:solidFill>
+            <a:prstDash val="solid"/>
+          </a:ln>
+        </p:spPr>
+      </p:sp>
+      <p:sp>
+        <p:nvSpPr>
+          <p:cNvPr id="13" name="Text 11"/>
+          <p:cNvSpPr txBox="1"/>
+          <p:nvPr/>
+        </p:nvSpPr>
+        <p:spPr>
+          <a:xfrm>
+            <a:off x="3401568" y="2322576"/>
+            <a:ext cx="2176272" cy="182880"/>
+          </a:xfrm>
+          <a:prstGeom prst="rect">
+            <a:avLst/>
+          </a:prstGeom>
+          <a:noFill/>
+          <a:ln/>
+        </p:spPr>
+        <p:txBody>
+          <a:bodyPr wrap="square" lIns="0" tIns="0" rIns="0" bIns="0" rtlCol="0" anchor="ctr"/>
+          <a:lstStyle/>
+          <a:p>
+            <a:pPr indent="0" marL="0">
+              <a:buNone/>
+            </a:pPr>
+            <a:r>
+              <a:rPr lang="en-US" sz="950" b="1" spc="80" kern="0" dirty="0">
+                <a:solidFill>
+                  <a:srgbClr val="1A1A1A"/>
+                </a:solidFill>
+                <a:latin typeface="Arial" pitchFamily="34" charset="0"/>
+                <a:ea typeface="Arial" pitchFamily="34" charset="-122"/>
+                <a:cs typeface="Arial" pitchFamily="34" charset="-120"/>
+              </a:rPr>
+              <a:t>SANATÇI</a:t>
+            </a:r>
+            <a:endParaRPr lang="en-US" sz="950" dirty="0"/>
+          </a:p>
+        </p:txBody>
+      </p:sp>
+      <p:sp>
+        <p:nvSpPr>
+          <p:cNvPr id="14" name="Shape 12"/>
+          <p:cNvSpPr/>
+          <p:nvPr/>
+        </p:nvSpPr>
+        <p:spPr>
+          <a:xfrm>
+            <a:off x="640080" y="3255264"/>
+            <a:ext cx="5065776" cy="1783080"/>
+          </a:xfrm>
+          <a:prstGeom prst="rect">
+            <a:avLst/>
+          </a:prstGeom>
+          <a:ln w="12700">
+            <a:solidFill>
+              <a:srgbClr val="1A1A1A"/>
+            </a:solidFill>
+            <a:prstDash val="solid"/>
+          </a:ln>
+        </p:spPr>
+      </p:sp>
+      <p:sp>
+        <p:nvSpPr>
+          <p:cNvPr id="15" name="Text 13"/>
+          <p:cNvSpPr txBox="1"/>
+          <p:nvPr/>
+        </p:nvSpPr>
+        <p:spPr>
+          <a:xfrm>
+            <a:off x="768096" y="3364992"/>
+            <a:ext cx="4809744" cy="182880"/>
           </a:xfrm>
           <a:prstGeom prst="rect">
             <a:avLst/>
@@ -1742,14 +2047,14 @@
       </p:sp>
       <p:sp>
         <p:nvSpPr>
-          <p:cNvPr id="6" name="Shape 4"/>
+          <p:cNvPr id="16" name="Shape 14"/>
           <p:cNvSpPr/>
           <p:nvPr/>
         </p:nvSpPr>
         <p:spPr>
           <a:xfrm>
-            <a:off x="685800" y="3236976"/>
-            <a:ext cx="3108960" cy="1517904"/>
+            <a:off x="640080" y="5239512"/>
+            <a:ext cx="5065776" cy="2542032"/>
           </a:xfrm>
           <a:prstGeom prst="rect">
             <a:avLst/>
@@ -1764,14 +2069,14 @@
       </p:sp>
       <p:sp>
         <p:nvSpPr>
-          <p:cNvPr id="7" name="Text 5"/>
+          <p:cNvPr id="17" name="Text 15"/>
           <p:cNvSpPr txBox="1"/>
           <p:nvPr/>
         </p:nvSpPr>
         <p:spPr>
           <a:xfrm>
-            <a:off x="813816" y="3346704"/>
-            <a:ext cx="2852928" cy="182880"/>
+            <a:off x="768096" y="5349240"/>
+            <a:ext cx="4809744" cy="182880"/>
           </a:xfrm>
           <a:prstGeom prst="rect">
             <a:avLst/>
@@ -1803,14 +2108,14 @@
       </p:sp>
       <p:sp>
         <p:nvSpPr>
-          <p:cNvPr id="8" name="Shape 6"/>
+          <p:cNvPr id="18" name="Shape 16"/>
           <p:cNvSpPr/>
           <p:nvPr/>
         </p:nvSpPr>
         <p:spPr>
           <a:xfrm>
-            <a:off x="3995928" y="1280160"/>
-            <a:ext cx="1868424" cy="713232"/>
+            <a:off x="640080" y="7982712"/>
+            <a:ext cx="5065776" cy="1892808"/>
           </a:xfrm>
           <a:prstGeom prst="rect">
             <a:avLst/>
@@ -1825,319 +2130,14 @@
       </p:sp>
       <p:sp>
         <p:nvSpPr>
-          <p:cNvPr id="9" name="Text 7"/>
-          <p:cNvSpPr txBox="1"/>
-          <p:nvPr/>
-        </p:nvSpPr>
-        <p:spPr>
-          <a:xfrm>
-            <a:off x="4123944" y="1389888"/>
-            <a:ext cx="1612392" cy="182880"/>
-          </a:xfrm>
-          <a:prstGeom prst="rect">
-            <a:avLst/>
-          </a:prstGeom>
-          <a:noFill/>
-          <a:ln/>
-        </p:spPr>
-        <p:txBody>
-          <a:bodyPr wrap="square" lIns="0" tIns="0" rIns="0" bIns="0" rtlCol="0" anchor="ctr"/>
-          <a:lstStyle/>
-          <a:p>
-            <a:pPr indent="0" marL="0">
-              <a:buNone/>
-            </a:pPr>
-            <a:r>
-              <a:rPr lang="en-US" sz="950" b="1" spc="80" kern="0" dirty="0">
-                <a:solidFill>
-                  <a:srgbClr val="1A1A1A"/>
-                </a:solidFill>
-                <a:latin typeface="Arial" pitchFamily="34" charset="0"/>
-                <a:ea typeface="Arial" pitchFamily="34" charset="-122"/>
-                <a:cs typeface="Arial" pitchFamily="34" charset="-120"/>
-              </a:rPr>
-              <a:t>AD SOYAD</a:t>
-            </a:r>
-            <a:endParaRPr lang="en-US" sz="950" dirty="0"/>
-          </a:p>
-        </p:txBody>
-      </p:sp>
-      <p:sp>
-        <p:nvSpPr>
-          <p:cNvPr id="10" name="Shape 8"/>
-          <p:cNvSpPr/>
-          <p:nvPr/>
-        </p:nvSpPr>
-        <p:spPr>
-          <a:xfrm>
-            <a:off x="6065520" y="1280160"/>
-            <a:ext cx="1868424" cy="713232"/>
-          </a:xfrm>
-          <a:prstGeom prst="rect">
-            <a:avLst/>
-          </a:prstGeom>
-          <a:ln w="12700">
-            <a:solidFill>
-              <a:srgbClr val="1A1A1A"/>
-            </a:solidFill>
-            <a:prstDash val="solid"/>
-          </a:ln>
-        </p:spPr>
-      </p:sp>
-      <p:sp>
-        <p:nvSpPr>
-          <p:cNvPr id="11" name="Text 9"/>
-          <p:cNvSpPr txBox="1"/>
-          <p:nvPr/>
-        </p:nvSpPr>
-        <p:spPr>
-          <a:xfrm>
-            <a:off x="6193536" y="1389888"/>
-            <a:ext cx="1612392" cy="182880"/>
-          </a:xfrm>
-          <a:prstGeom prst="rect">
-            <a:avLst/>
-          </a:prstGeom>
-          <a:noFill/>
-          <a:ln/>
-        </p:spPr>
-        <p:txBody>
-          <a:bodyPr wrap="square" lIns="0" tIns="0" rIns="0" bIns="0" rtlCol="0" anchor="ctr"/>
-          <a:lstStyle/>
-          <a:p>
-            <a:pPr indent="0" marL="0">
-              <a:buNone/>
-            </a:pPr>
-            <a:r>
-              <a:rPr lang="en-US" sz="950" b="1" spc="80" kern="0" dirty="0">
-                <a:solidFill>
-                  <a:srgbClr val="1A1A1A"/>
-                </a:solidFill>
-                <a:latin typeface="Arial" pitchFamily="34" charset="0"/>
-                <a:ea typeface="Arial" pitchFamily="34" charset="-122"/>
-                <a:cs typeface="Arial" pitchFamily="34" charset="-120"/>
-              </a:rPr>
-              <a:t>ÖĞRENCİ NO</a:t>
-            </a:r>
-            <a:endParaRPr lang="en-US" sz="950" dirty="0"/>
-          </a:p>
-        </p:txBody>
-      </p:sp>
-      <p:sp>
-        <p:nvSpPr>
-          <p:cNvPr id="12" name="Shape 10"/>
-          <p:cNvSpPr/>
-          <p:nvPr/>
-        </p:nvSpPr>
-        <p:spPr>
-          <a:xfrm>
-            <a:off x="8135112" y="1280160"/>
-            <a:ext cx="1868424" cy="713232"/>
-          </a:xfrm>
-          <a:prstGeom prst="rect">
-            <a:avLst/>
-          </a:prstGeom>
-          <a:ln w="12700">
-            <a:solidFill>
-              <a:srgbClr val="1A1A1A"/>
-            </a:solidFill>
-            <a:prstDash val="solid"/>
-          </a:ln>
-        </p:spPr>
-      </p:sp>
-      <p:sp>
-        <p:nvSpPr>
-          <p:cNvPr id="13" name="Text 11"/>
-          <p:cNvSpPr txBox="1"/>
-          <p:nvPr/>
-        </p:nvSpPr>
-        <p:spPr>
-          <a:xfrm>
-            <a:off x="8263128" y="1389888"/>
-            <a:ext cx="1612392" cy="182880"/>
-          </a:xfrm>
-          <a:prstGeom prst="rect">
-            <a:avLst/>
-          </a:prstGeom>
-          <a:noFill/>
-          <a:ln/>
-        </p:spPr>
-        <p:txBody>
-          <a:bodyPr wrap="square" lIns="0" tIns="0" rIns="0" bIns="0" rtlCol="0" anchor="ctr"/>
-          <a:lstStyle/>
-          <a:p>
-            <a:pPr indent="0" marL="0">
-              <a:buNone/>
-            </a:pPr>
-            <a:r>
-              <a:rPr lang="en-US" sz="950" b="1" spc="80" kern="0" dirty="0">
-                <a:solidFill>
-                  <a:srgbClr val="1A1A1A"/>
-                </a:solidFill>
-                <a:latin typeface="Arial" pitchFamily="34" charset="0"/>
-                <a:ea typeface="Arial" pitchFamily="34" charset="-122"/>
-                <a:cs typeface="Arial" pitchFamily="34" charset="-120"/>
-              </a:rPr>
-              <a:t>TARİH</a:t>
-            </a:r>
-            <a:endParaRPr lang="en-US" sz="950" dirty="0"/>
-          </a:p>
-        </p:txBody>
-      </p:sp>
-      <p:sp>
-        <p:nvSpPr>
-          <p:cNvPr id="14" name="Shape 12"/>
-          <p:cNvSpPr/>
-          <p:nvPr/>
-        </p:nvSpPr>
-        <p:spPr>
-          <a:xfrm>
-            <a:off x="3995928" y="2194560"/>
-            <a:ext cx="2903220" cy="841248"/>
-          </a:xfrm>
-          <a:prstGeom prst="rect">
-            <a:avLst/>
-          </a:prstGeom>
-          <a:ln w="12700">
-            <a:solidFill>
-              <a:srgbClr val="1A1A1A"/>
-            </a:solidFill>
-            <a:prstDash val="solid"/>
-          </a:ln>
-        </p:spPr>
-      </p:sp>
-      <p:sp>
-        <p:nvSpPr>
-          <p:cNvPr id="15" name="Text 13"/>
-          <p:cNvSpPr txBox="1"/>
-          <p:nvPr/>
-        </p:nvSpPr>
-        <p:spPr>
-          <a:xfrm>
-            <a:off x="4123944" y="2304288"/>
-            <a:ext cx="2647188" cy="182880"/>
-          </a:xfrm>
-          <a:prstGeom prst="rect">
-            <a:avLst/>
-          </a:prstGeom>
-          <a:noFill/>
-          <a:ln/>
-        </p:spPr>
-        <p:txBody>
-          <a:bodyPr wrap="square" lIns="0" tIns="0" rIns="0" bIns="0" rtlCol="0" anchor="ctr"/>
-          <a:lstStyle/>
-          <a:p>
-            <a:pPr indent="0" marL="0">
-              <a:buNone/>
-            </a:pPr>
-            <a:r>
-              <a:rPr lang="en-US" sz="950" b="1" spc="80" kern="0" dirty="0">
-                <a:solidFill>
-                  <a:srgbClr val="1A1A1A"/>
-                </a:solidFill>
-                <a:latin typeface="Arial" pitchFamily="34" charset="0"/>
-                <a:ea typeface="Arial" pitchFamily="34" charset="-122"/>
-                <a:cs typeface="Arial" pitchFamily="34" charset="-120"/>
-              </a:rPr>
-              <a:t>ESER ADI</a:t>
-            </a:r>
-            <a:endParaRPr lang="en-US" sz="950" dirty="0"/>
-          </a:p>
-        </p:txBody>
-      </p:sp>
-      <p:sp>
-        <p:nvSpPr>
-          <p:cNvPr id="16" name="Shape 14"/>
-          <p:cNvSpPr/>
-          <p:nvPr/>
-        </p:nvSpPr>
-        <p:spPr>
-          <a:xfrm>
-            <a:off x="7100316" y="2194560"/>
-            <a:ext cx="2903220" cy="841248"/>
-          </a:xfrm>
-          <a:prstGeom prst="rect">
-            <a:avLst/>
-          </a:prstGeom>
-          <a:ln w="12700">
-            <a:solidFill>
-              <a:srgbClr val="1A1A1A"/>
-            </a:solidFill>
-            <a:prstDash val="solid"/>
-          </a:ln>
-        </p:spPr>
-      </p:sp>
-      <p:sp>
-        <p:nvSpPr>
-          <p:cNvPr id="17" name="Text 15"/>
-          <p:cNvSpPr txBox="1"/>
-          <p:nvPr/>
-        </p:nvSpPr>
-        <p:spPr>
-          <a:xfrm>
-            <a:off x="7228332" y="2304288"/>
-            <a:ext cx="2647188" cy="182880"/>
-          </a:xfrm>
-          <a:prstGeom prst="rect">
-            <a:avLst/>
-          </a:prstGeom>
-          <a:noFill/>
-          <a:ln/>
-        </p:spPr>
-        <p:txBody>
-          <a:bodyPr wrap="square" lIns="0" tIns="0" rIns="0" bIns="0" rtlCol="0" anchor="ctr"/>
-          <a:lstStyle/>
-          <a:p>
-            <a:pPr indent="0" marL="0">
-              <a:buNone/>
-            </a:pPr>
-            <a:r>
-              <a:rPr lang="en-US" sz="950" b="1" spc="80" kern="0" dirty="0">
-                <a:solidFill>
-                  <a:srgbClr val="1A1A1A"/>
-                </a:solidFill>
-                <a:latin typeface="Arial" pitchFamily="34" charset="0"/>
-                <a:ea typeface="Arial" pitchFamily="34" charset="-122"/>
-                <a:cs typeface="Arial" pitchFamily="34" charset="-120"/>
-              </a:rPr>
-              <a:t>SANATÇI</a:t>
-            </a:r>
-            <a:endParaRPr lang="en-US" sz="950" dirty="0"/>
-          </a:p>
-        </p:txBody>
-      </p:sp>
-      <p:sp>
-        <p:nvSpPr>
-          <p:cNvPr id="18" name="Shape 16"/>
-          <p:cNvSpPr/>
-          <p:nvPr/>
-        </p:nvSpPr>
-        <p:spPr>
-          <a:xfrm>
-            <a:off x="3995928" y="3236976"/>
-            <a:ext cx="6007608" cy="1517904"/>
-          </a:xfrm>
-          <a:prstGeom prst="rect">
-            <a:avLst/>
-          </a:prstGeom>
-          <a:ln w="12700">
-            <a:solidFill>
-              <a:srgbClr val="1A1A1A"/>
-            </a:solidFill>
-            <a:prstDash val="solid"/>
-          </a:ln>
-        </p:spPr>
-      </p:sp>
-      <p:sp>
-        <p:nvSpPr>
           <p:cNvPr id="19" name="Text 17"/>
           <p:cNvSpPr txBox="1"/>
           <p:nvPr/>
         </p:nvSpPr>
         <p:spPr>
           <a:xfrm>
-            <a:off x="4123944" y="3346704"/>
-            <a:ext cx="5751576" cy="182880"/>
+            <a:off x="768096" y="8092440"/>
+            <a:ext cx="4809744" cy="182880"/>
           </a:xfrm>
           <a:prstGeom prst="rect">
             <a:avLst/>
@@ -2169,14 +2169,36 @@
       </p:sp>
       <p:sp>
         <p:nvSpPr>
-          <p:cNvPr id="20" name="Text 18"/>
+          <p:cNvPr id="20" name="Shape 18"/>
+          <p:cNvSpPr/>
+          <p:nvPr/>
+        </p:nvSpPr>
+        <p:spPr>
+          <a:xfrm>
+            <a:off x="5907024" y="1298448"/>
+            <a:ext cx="8577072" cy="8577072"/>
+          </a:xfrm>
+          <a:prstGeom prst="rect">
+            <a:avLst/>
+          </a:prstGeom>
+          <a:ln w="12700">
+            <a:solidFill>
+              <a:srgbClr val="1A1A1A"/>
+            </a:solidFill>
+            <a:prstDash val="solid"/>
+          </a:ln>
+        </p:spPr>
+      </p:sp>
+      <p:sp>
+        <p:nvSpPr>
+          <p:cNvPr id="21" name="Text 19"/>
           <p:cNvSpPr txBox="1"/>
           <p:nvPr/>
         </p:nvSpPr>
         <p:spPr>
           <a:xfrm>
-            <a:off x="685800" y="4956048"/>
-            <a:ext cx="9317736" cy="164592"/>
+            <a:off x="6035040" y="1408176"/>
+            <a:ext cx="8321040" cy="182880"/>
           </a:xfrm>
           <a:prstGeom prst="rect">
             <a:avLst/>
@@ -2208,36 +2230,14 @@
       </p:sp>
       <p:sp>
         <p:nvSpPr>
-          <p:cNvPr id="21" name="Shape 19"/>
-          <p:cNvSpPr/>
-          <p:nvPr/>
-        </p:nvSpPr>
-        <p:spPr>
-          <a:xfrm>
-            <a:off x="685800" y="5148072"/>
-            <a:ext cx="9317736" cy="9317736"/>
-          </a:xfrm>
-          <a:prstGeom prst="rect">
-            <a:avLst/>
-          </a:prstGeom>
-          <a:ln w="12700">
-            <a:solidFill>
-              <a:srgbClr val="1A1A1A"/>
-            </a:solidFill>
-            <a:prstDash val="solid"/>
-          </a:ln>
-        </p:spPr>
-      </p:sp>
-      <p:sp>
-        <p:nvSpPr>
           <p:cNvPr id="22" name="Text 20"/>
           <p:cNvSpPr txBox="1"/>
           <p:nvPr/>
         </p:nvSpPr>
         <p:spPr>
           <a:xfrm>
-            <a:off x="685800" y="14593824"/>
-            <a:ext cx="9317736" cy="164592"/>
+            <a:off x="640080" y="10021824"/>
+            <a:ext cx="13844016" cy="164592"/>
           </a:xfrm>
           <a:prstGeom prst="rect">
             <a:avLst/>

</xml_diff>